<commit_message>
Swap TRD1/TRD2 transports; check SmartHeap against glibc
TRD1 now uses multicast (LBT-RM) and TRD2 uses SRS (LBT-RU). Move the SRS
and lbmrd host to .121, trim the shared context defaults, and update the
README text and figure to match. Note that Mon TRD has no DRO endpoint.

tst.sh (both demos) now checks that the first libsmartheap_smp64.so on
LD_LIBRARY_PATH suits the host's glibc, since a mismatch crashes the Store
silently. lbm.sh.example initializes LBM_ERR, which tst.sh tests.

Co-Authored-By: Claude Sonnet 5.5 <noreply@anthropic.com>
</commit_message>
<xml_diff>
--- a/figure1.pptx
+++ b/figure1.pptx
@@ -259,7 +259,7 @@
           <a:p>
             <a:fld id="{B99F8C3E-267A-5347-9FF5-3C775BC7331A}" type="datetimeFigureOut">
               <a:rPr lang="en-US" smtClean="0"/>
-              <a:t>10/29/2023</a:t>
+              <a:t>10/26/2026</a:t>
             </a:fld>
             <a:endParaRPr lang="en-US"/>
           </a:p>
@@ -457,7 +457,7 @@
           <a:p>
             <a:fld id="{B99F8C3E-267A-5347-9FF5-3C775BC7331A}" type="datetimeFigureOut">
               <a:rPr lang="en-US" smtClean="0"/>
-              <a:t>10/29/2023</a:t>
+              <a:t>10/26/2026</a:t>
             </a:fld>
             <a:endParaRPr lang="en-US"/>
           </a:p>
@@ -665,7 +665,7 @@
           <a:p>
             <a:fld id="{B99F8C3E-267A-5347-9FF5-3C775BC7331A}" type="datetimeFigureOut">
               <a:rPr lang="en-US" smtClean="0"/>
-              <a:t>10/29/2023</a:t>
+              <a:t>10/26/2026</a:t>
             </a:fld>
             <a:endParaRPr lang="en-US"/>
           </a:p>
@@ -863,7 +863,7 @@
           <a:p>
             <a:fld id="{B99F8C3E-267A-5347-9FF5-3C775BC7331A}" type="datetimeFigureOut">
               <a:rPr lang="en-US" smtClean="0"/>
-              <a:t>10/29/2023</a:t>
+              <a:t>10/26/2026</a:t>
             </a:fld>
             <a:endParaRPr lang="en-US"/>
           </a:p>
@@ -1138,7 +1138,7 @@
           <a:p>
             <a:fld id="{B99F8C3E-267A-5347-9FF5-3C775BC7331A}" type="datetimeFigureOut">
               <a:rPr lang="en-US" smtClean="0"/>
-              <a:t>10/29/2023</a:t>
+              <a:t>10/26/2026</a:t>
             </a:fld>
             <a:endParaRPr lang="en-US"/>
           </a:p>
@@ -1403,7 +1403,7 @@
           <a:p>
             <a:fld id="{B99F8C3E-267A-5347-9FF5-3C775BC7331A}" type="datetimeFigureOut">
               <a:rPr lang="en-US" smtClean="0"/>
-              <a:t>10/29/2023</a:t>
+              <a:t>10/26/2026</a:t>
             </a:fld>
             <a:endParaRPr lang="en-US"/>
           </a:p>
@@ -1815,7 +1815,7 @@
           <a:p>
             <a:fld id="{B99F8C3E-267A-5347-9FF5-3C775BC7331A}" type="datetimeFigureOut">
               <a:rPr lang="en-US" smtClean="0"/>
-              <a:t>10/29/2023</a:t>
+              <a:t>10/26/2026</a:t>
             </a:fld>
             <a:endParaRPr lang="en-US"/>
           </a:p>
@@ -1956,7 +1956,7 @@
           <a:p>
             <a:fld id="{B99F8C3E-267A-5347-9FF5-3C775BC7331A}" type="datetimeFigureOut">
               <a:rPr lang="en-US" smtClean="0"/>
-              <a:t>10/29/2023</a:t>
+              <a:t>10/26/2026</a:t>
             </a:fld>
             <a:endParaRPr lang="en-US"/>
           </a:p>
@@ -2069,7 +2069,7 @@
           <a:p>
             <a:fld id="{B99F8C3E-267A-5347-9FF5-3C775BC7331A}" type="datetimeFigureOut">
               <a:rPr lang="en-US" smtClean="0"/>
-              <a:t>10/29/2023</a:t>
+              <a:t>10/26/2026</a:t>
             </a:fld>
             <a:endParaRPr lang="en-US"/>
           </a:p>
@@ -2380,7 +2380,7 @@
           <a:p>
             <a:fld id="{B99F8C3E-267A-5347-9FF5-3C775BC7331A}" type="datetimeFigureOut">
               <a:rPr lang="en-US" smtClean="0"/>
-              <a:t>10/29/2023</a:t>
+              <a:t>10/26/2026</a:t>
             </a:fld>
             <a:endParaRPr lang="en-US"/>
           </a:p>
@@ -2668,7 +2668,7 @@
           <a:p>
             <a:fld id="{B99F8C3E-267A-5347-9FF5-3C775BC7331A}" type="datetimeFigureOut">
               <a:rPr lang="en-US" smtClean="0"/>
-              <a:t>10/29/2023</a:t>
+              <a:t>10/26/2026</a:t>
             </a:fld>
             <a:endParaRPr lang="en-US"/>
           </a:p>
@@ -2909,7 +2909,7 @@
           <a:p>
             <a:fld id="{B99F8C3E-267A-5347-9FF5-3C775BC7331A}" type="datetimeFigureOut">
               <a:rPr lang="en-US" smtClean="0"/>
-              <a:t>10/29/2023</a:t>
+              <a:t>10/26/2026</a:t>
             </a:fld>
             <a:endParaRPr lang="en-US"/>
           </a:p>
@@ -3682,7 +3682,7 @@
         </p:nvSpPr>
         <p:spPr>
           <a:xfrm>
-            <a:off x="4832248" y="1430287"/>
+            <a:off x="4977076" y="1887005"/>
             <a:ext cx="516488" cy="276999"/>
           </a:xfrm>
           <a:prstGeom prst="rect">
@@ -4367,7 +4367,7 @@
         </p:nvSpPr>
         <p:spPr>
           <a:xfrm>
-            <a:off x="1947771" y="969549"/>
+            <a:off x="8874923" y="1405880"/>
             <a:ext cx="1348734" cy="921475"/>
           </a:xfrm>
           <a:prstGeom prst="rect">
@@ -4415,7 +4415,7 @@
         </p:nvSpPr>
         <p:spPr>
           <a:xfrm>
-            <a:off x="2387715" y="972814"/>
+            <a:off x="9477497" y="1409145"/>
             <a:ext cx="407035" cy="276999"/>
           </a:xfrm>
           <a:prstGeom prst="rect">
@@ -4447,13 +4447,12 @@
           </p:cNvPr>
           <p:cNvCxnSpPr>
             <a:cxnSpLocks/>
-            <a:endCxn id="74" idx="3"/>
           </p:cNvCxnSpPr>
           <p:nvPr/>
         </p:nvCxnSpPr>
         <p:spPr>
           <a:xfrm flipH="1">
-            <a:off x="3296505" y="1430287"/>
+            <a:off x="8118783" y="2036168"/>
             <a:ext cx="764342" cy="0"/>
           </a:xfrm>
           <a:prstGeom prst="line">
@@ -4494,8 +4493,8 @@
         </p:nvSpPr>
         <p:spPr>
           <a:xfrm>
-            <a:off x="1212487" y="1265774"/>
-            <a:ext cx="4441226" cy="3306413"/>
+            <a:off x="1212487" y="1605123"/>
+            <a:ext cx="4441226" cy="2967064"/>
           </a:xfrm>
           <a:prstGeom prst="ellipse">
             <a:avLst/>
@@ -4547,8 +4546,8 @@
         </p:nvSpPr>
         <p:spPr>
           <a:xfrm>
-            <a:off x="6477331" y="1871207"/>
-            <a:ext cx="5406344" cy="2083770"/>
+            <a:off x="6477331" y="1824643"/>
+            <a:ext cx="4770727" cy="2130334"/>
           </a:xfrm>
           <a:prstGeom prst="ellipse">
             <a:avLst/>
@@ -5204,14 +5203,13 @@
           </p:cNvPr>
           <p:cNvCxnSpPr>
             <a:cxnSpLocks/>
-            <a:endCxn id="74" idx="1"/>
           </p:cNvCxnSpPr>
           <p:nvPr/>
         </p:nvCxnSpPr>
         <p:spPr>
-          <a:xfrm flipV="1">
-            <a:off x="212454" y="1430287"/>
-            <a:ext cx="1735317" cy="921475"/>
+          <a:xfrm>
+            <a:off x="10223657" y="1707286"/>
+            <a:ext cx="1432682" cy="815656"/>
           </a:xfrm>
           <a:prstGeom prst="line">
             <a:avLst/>
@@ -5253,7 +5251,7 @@
         </p:nvCxnSpPr>
         <p:spPr>
           <a:xfrm>
-            <a:off x="212454" y="2368406"/>
+            <a:off x="11656339" y="2506905"/>
             <a:ext cx="0" cy="2843674"/>
           </a:xfrm>
           <a:prstGeom prst="line">
@@ -5295,9 +5293,9 @@
           <p:nvPr/>
         </p:nvCxnSpPr>
         <p:spPr>
-          <a:xfrm>
-            <a:off x="212454" y="5212080"/>
-            <a:ext cx="5883546" cy="320040"/>
+          <a:xfrm flipH="1">
+            <a:off x="6096000" y="5332699"/>
+            <a:ext cx="5560339" cy="199421"/>
           </a:xfrm>
           <a:prstGeom prst="line">
             <a:avLst/>
@@ -5337,7 +5335,7 @@
         </p:nvSpPr>
         <p:spPr>
           <a:xfrm>
-            <a:off x="1104650" y="1213829"/>
+            <a:off x="10306413" y="1547644"/>
             <a:ext cx="858889" cy="276999"/>
           </a:xfrm>
           <a:prstGeom prst="rect">
@@ -5944,4 +5942,10 @@
     </a:ext>
   </a:extLst>
 </a:theme>
+</file>
+
+<file path=docMetadata/LabelInfo.xml><?xml version="1.0" encoding="utf-8"?>
+<clbl:labelList xmlns:clbl="http://schemas.microsoft.com/office/2020/mipLabelMetadata">
+  <clbl:label id="{14c8150c-bc7e-4d77-82d5-2d0905f0cd74}" enabled="1" method="Standard" siteId="{2638f43e-f77d-4fc7-ab92-7b753b7876fd}" contentBits="0" removed="0"/>
+</clbl:labelList>
 </file>
</xml_diff>